<commit_message>
Finish documentation demo content
</commit_message>
<xml_diff>
--- a/2025-06-24-automagical-documentation/documentation-slides.pptx
+++ b/2025-06-24-automagical-documentation/documentation-slides.pptx
@@ -27,8 +27,8 @@
     <p:sldId id="284" r:id="rId18"/>
     <p:sldId id="285" r:id="rId19"/>
     <p:sldId id="286" r:id="rId20"/>
-    <p:sldId id="264" r:id="rId21"/>
-    <p:sldId id="274" r:id="rId22"/>
+    <p:sldId id="287" r:id="rId21"/>
+    <p:sldId id="264" r:id="rId22"/>
     <p:sldId id="265" r:id="rId23"/>
   </p:sldIdLst>
   <p:sldSz cx="12192000" cy="6858000"/>
@@ -150,8 +150,8 @@
             <p14:sldId id="284"/>
             <p14:sldId id="285"/>
             <p14:sldId id="286"/>
+            <p14:sldId id="287"/>
             <p14:sldId id="264"/>
-            <p14:sldId id="274"/>
             <p14:sldId id="265"/>
           </p14:sldIdLst>
         </p14:section>
@@ -261,7 +261,7 @@
           <a:p>
             <a:fld id="{69440670-43D7-400A-ABC5-B69E064DBB37}" type="datetimeFigureOut">
               <a:rPr lang="en-GB" smtClean="0"/>
-              <a:t>08/06/2025</a:t>
+              <a:t>16/06/2025</a:t>
             </a:fld>
             <a:endParaRPr lang="en-GB" dirty="0"/>
           </a:p>
@@ -438,7 +438,7 @@
           <a:p>
             <a:fld id="{611B03A4-75C9-4E3D-9183-2102CA9AEC33}" type="datetimeFigureOut">
               <a:rPr lang="en-GB" smtClean="0"/>
-              <a:t>08/06/2025</a:t>
+              <a:t>16/06/2025</a:t>
             </a:fld>
             <a:endParaRPr lang="en-GB" dirty="0"/>
           </a:p>
@@ -1586,6 +1586,114 @@
     <p:extLst>
       <p:ext uri="{BB962C8B-B14F-4D97-AF65-F5344CB8AC3E}">
         <p14:creationId xmlns:p14="http://schemas.microsoft.com/office/powerpoint/2010/main" val="3008383762"/>
+      </p:ext>
+    </p:extLst>
+  </p:cSld>
+  <p:clrMapOvr>
+    <a:masterClrMapping/>
+  </p:clrMapOvr>
+</p:notes>
+</file>
+
+<file path=ppt/notesSlides/notesSlide12.xml><?xml version="1.0" encoding="utf-8"?>
+<p:notes xmlns:a="http://schemas.openxmlformats.org/drawingml/2006/main" xmlns:r="http://schemas.openxmlformats.org/officeDocument/2006/relationships" xmlns:p="http://schemas.openxmlformats.org/presentationml/2006/main">
+  <p:cSld>
+    <p:spTree>
+      <p:nvGrpSpPr>
+        <p:cNvPr id="1" name="">
+          <a:extLst>
+            <a:ext uri="{FF2B5EF4-FFF2-40B4-BE49-F238E27FC236}">
+              <a16:creationId xmlns:a16="http://schemas.microsoft.com/office/drawing/2014/main" id="{0530C720-2939-0470-DEDB-3226B948A25F}"/>
+            </a:ext>
+          </a:extLst>
+        </p:cNvPr>
+        <p:cNvGrpSpPr/>
+        <p:nvPr/>
+      </p:nvGrpSpPr>
+      <p:grpSpPr>
+        <a:xfrm>
+          <a:off x="0" y="0"/>
+          <a:ext cx="0" cy="0"/>
+          <a:chOff x="0" y="0"/>
+          <a:chExt cx="0" cy="0"/>
+        </a:xfrm>
+      </p:grpSpPr>
+      <p:sp>
+        <p:nvSpPr>
+          <p:cNvPr id="2" name="Espace réservé de l'image des diapositives 1">
+            <a:extLst>
+              <a:ext uri="{FF2B5EF4-FFF2-40B4-BE49-F238E27FC236}">
+                <a16:creationId xmlns:a16="http://schemas.microsoft.com/office/drawing/2014/main" id="{CB02892E-CC25-2DF7-05D1-C7F473F04BCE}"/>
+              </a:ext>
+            </a:extLst>
+          </p:cNvPr>
+          <p:cNvSpPr>
+            <a:spLocks noGrp="1" noRot="1" noChangeAspect="1"/>
+          </p:cNvSpPr>
+          <p:nvPr>
+            <p:ph type="sldImg"/>
+          </p:nvPr>
+        </p:nvSpPr>
+        <p:spPr/>
+      </p:sp>
+      <p:sp>
+        <p:nvSpPr>
+          <p:cNvPr id="3" name="Espace réservé des notes 2">
+            <a:extLst>
+              <a:ext uri="{FF2B5EF4-FFF2-40B4-BE49-F238E27FC236}">
+                <a16:creationId xmlns:a16="http://schemas.microsoft.com/office/drawing/2014/main" id="{8002F57E-D32E-840C-7A0D-048413B9AC48}"/>
+              </a:ext>
+            </a:extLst>
+          </p:cNvPr>
+          <p:cNvSpPr>
+            <a:spLocks noGrp="1"/>
+          </p:cNvSpPr>
+          <p:nvPr>
+            <p:ph type="body" idx="1"/>
+          </p:nvPr>
+        </p:nvSpPr>
+        <p:spPr/>
+        <p:txBody>
+          <a:bodyPr/>
+          <a:lstStyle/>
+          <a:p>
+            <a:endParaRPr lang="en-GB" dirty="0"/>
+          </a:p>
+        </p:txBody>
+      </p:sp>
+      <p:sp>
+        <p:nvSpPr>
+          <p:cNvPr id="4" name="Espace réservé du numéro de diapositive 3">
+            <a:extLst>
+              <a:ext uri="{FF2B5EF4-FFF2-40B4-BE49-F238E27FC236}">
+                <a16:creationId xmlns:a16="http://schemas.microsoft.com/office/drawing/2014/main" id="{37B39A90-0A51-3F84-67C6-B71DE0CF8664}"/>
+              </a:ext>
+            </a:extLst>
+          </p:cNvPr>
+          <p:cNvSpPr>
+            <a:spLocks noGrp="1"/>
+          </p:cNvSpPr>
+          <p:nvPr>
+            <p:ph type="sldNum" sz="quarter" idx="5"/>
+          </p:nvPr>
+        </p:nvSpPr>
+        <p:spPr/>
+        <p:txBody>
+          <a:bodyPr/>
+          <a:lstStyle/>
+          <a:p>
+            <a:fld id="{A7839206-A81D-4F76-8486-302187992F73}" type="slidenum">
+              <a:rPr lang="en-GB" smtClean="0"/>
+              <a:t>14</a:t>
+            </a:fld>
+            <a:endParaRPr lang="en-GB" dirty="0"/>
+          </a:p>
+        </p:txBody>
+      </p:sp>
+    </p:spTree>
+    <p:extLst>
+      <p:ext uri="{BB962C8B-B14F-4D97-AF65-F5344CB8AC3E}">
+        <p14:creationId xmlns:p14="http://schemas.microsoft.com/office/powerpoint/2010/main" val="4067796740"/>
       </p:ext>
     </p:extLst>
   </p:cSld>
@@ -6809,7 +6917,16 @@
           <a:prstGeom prst="rect">
             <a:avLst/>
           </a:prstGeom>
-          <a:noFill/>
+          <a:ln>
+            <a:noFill/>
+          </a:ln>
+          <a:effectLst>
+            <a:outerShdw blurRad="292100" dist="139700" dir="2700000" algn="tl" rotWithShape="0">
+              <a:srgbClr val="333333">
+                <a:alpha val="65000"/>
+              </a:srgbClr>
+            </a:outerShdw>
+          </a:effectLst>
           <a:extLst>
             <a:ext uri="{909E8E84-426E-40DD-AFC4-6F175D3DCCD1}">
               <a14:hiddenFill xmlns:a14="http://schemas.microsoft.com/office/drawing/2010/main">
@@ -6882,7 +6999,7 @@
           <a:p>
             <a:r>
               <a:rPr lang="en-US" sz="4400" dirty="0"/>
-              <a:t>PwshSpectreConsole Help Generation</a:t>
+              <a:t>Help Generation Steps</a:t>
             </a:r>
             <a:endParaRPr lang="en-US" sz="4400" noProof="0" dirty="0"/>
           </a:p>
@@ -6927,63 +7044,36 @@
             <a:br>
               <a:rPr lang="en-US" sz="2800" noProof="0" dirty="0"/>
             </a:br>
-            <a:endParaRPr lang="en-US" sz="2800" noProof="0" dirty="0"/>
-          </a:p>
-          <a:p>
-            <a:pPr lvl="1"/>
-            <a:r>
-              <a:rPr lang="en-US" sz="2800" noProof="0" dirty="0"/>
-              <a:t>Generate</a:t>
-            </a:r>
-            <a:r>
-              <a:rPr lang="en-US" sz="2800" dirty="0"/>
-              <a:t> example recordings</a:t>
-            </a:r>
-          </a:p>
-          <a:p>
-            <a:pPr lvl="1"/>
+            <a:endParaRPr lang="en-US" sz="2800" dirty="0"/>
+          </a:p>
+          <a:p>
+            <a:pPr marL="971550" lvl="1" indent="-514350">
+              <a:buFont typeface="+mj-lt"/>
+              <a:buAutoNum type="arabicPeriod"/>
+            </a:pPr>
             <a:r>
               <a:rPr lang="en-US" sz="2800" dirty="0"/>
               <a:t>Dump Comment Based Help to Markdown</a:t>
             </a:r>
           </a:p>
           <a:p>
-            <a:pPr lvl="1"/>
+            <a:pPr marL="971550" lvl="1" indent="-514350">
+              <a:buFont typeface="+mj-lt"/>
+              <a:buAutoNum type="arabicPeriod"/>
+            </a:pPr>
             <a:r>
               <a:rPr lang="en-US" sz="2800" noProof="0" dirty="0"/>
-              <a:t>Replace the </a:t>
-            </a:r>
+              <a:t>Record all the Examples</a:t>
+            </a:r>
+          </a:p>
+          <a:p>
+            <a:pPr marL="971550" lvl="1" indent="-514350">
+              <a:buFont typeface="+mj-lt"/>
+              <a:buAutoNum type="arabicPeriod"/>
+            </a:pPr>
             <a:r>
               <a:rPr lang="en-US" sz="2800" dirty="0"/>
-              <a:t>examples in Markdown with recordings</a:t>
-            </a:r>
-          </a:p>
-          <a:p>
-            <a:pPr lvl="1"/>
-            <a:r>
-              <a:rPr lang="en-US" sz="2800" dirty="0"/>
-              <a:t>Update Markdown for Astro</a:t>
-            </a:r>
-          </a:p>
-          <a:p>
-            <a:pPr lvl="1"/>
-            <a:r>
-              <a:rPr lang="en-US" sz="2800" noProof="0" dirty="0"/>
-              <a:t>Copy Markdown to correct location for Astro</a:t>
-            </a:r>
-          </a:p>
-          <a:p>
-            <a:pPr lvl="1"/>
-            <a:r>
-              <a:rPr lang="en-US" sz="2800" noProof="0" dirty="0"/>
-              <a:t>Run the Astro website</a:t>
-            </a:r>
-          </a:p>
-          <a:p>
-            <a:pPr lvl="1"/>
-            <a:r>
-              <a:rPr lang="en-US" sz="2800" dirty="0"/>
-              <a:t>Deploy the Astro website</a:t>
+              <a:t>Embed everything in a Website</a:t>
             </a:r>
             <a:endParaRPr lang="en-US" noProof="0" dirty="0"/>
           </a:p>
@@ -7050,7 +7140,7 @@
           <a:p>
             <a:r>
               <a:rPr lang="en-US" sz="4400" dirty="0"/>
-              <a:t>Dump Help to Markdown</a:t>
+              <a:t>1. Dump Help to Markdown</a:t>
             </a:r>
             <a:endParaRPr lang="en-US" sz="4400" noProof="0" dirty="0"/>
           </a:p>
@@ -7095,436 +7185,82 @@
             <a:pPr lvl="1"/>
             <a:r>
               <a:rPr lang="en-US" sz="2400" noProof="0" dirty="0"/>
-              <a:t>Creates an object model of the help file that you can manipulate in memory</a:t>
+              <a:t>Create an object model of the help file that we can manipulate in memory</a:t>
             </a:r>
           </a:p>
           <a:p>
             <a:pPr lvl="1"/>
             <a:r>
               <a:rPr lang="en-US" sz="2400" dirty="0"/>
-              <a:t>Allows configuration of metadata (frontmatter)</a:t>
+              <a:t>Modify example data for recorded examples</a:t>
+            </a:r>
+            <a:endParaRPr lang="en-US" sz="2400" noProof="0" dirty="0"/>
+          </a:p>
+          <a:p>
+            <a:pPr lvl="1"/>
+            <a:r>
+              <a:rPr lang="en-US" sz="2400" dirty="0"/>
+              <a:t>Export to Markdown</a:t>
             </a:r>
           </a:p>
         </p:txBody>
       </p:sp>
-      <p:sp>
-        <p:nvSpPr>
-          <p:cNvPr id="5" name="TextBox 4">
+      <p:pic>
+        <p:nvPicPr>
+          <p:cNvPr id="2050" name="Picture 2">
             <a:extLst>
               <a:ext uri="{FF2B5EF4-FFF2-40B4-BE49-F238E27FC236}">
-                <a16:creationId xmlns:a16="http://schemas.microsoft.com/office/drawing/2014/main" id="{5C02D506-A4CC-DACE-6415-404FEBE6D0E6}"/>
+                <a16:creationId xmlns:a16="http://schemas.microsoft.com/office/drawing/2014/main" id="{11C5CB2C-17BA-92E0-E0DB-3E5A29982915}"/>
               </a:ext>
             </a:extLst>
           </p:cNvPr>
-          <p:cNvSpPr txBox="1"/>
+          <p:cNvPicPr>
+            <a:picLocks noChangeAspect="1" noChangeArrowheads="1"/>
+          </p:cNvPicPr>
           <p:nvPr/>
-        </p:nvSpPr>
-        <p:spPr>
+        </p:nvPicPr>
+        <p:blipFill>
+          <a:blip r:embed="rId3">
+            <a:extLst>
+              <a:ext uri="{28A0092B-C50C-407E-A947-70E740481C1C}">
+                <a14:useLocalDpi xmlns:a14="http://schemas.microsoft.com/office/drawing/2010/main" val="0"/>
+              </a:ext>
+            </a:extLst>
+          </a:blip>
+          <a:srcRect/>
+          <a:stretch>
+            <a:fillRect/>
+          </a:stretch>
+        </p:blipFill>
+        <p:spPr bwMode="auto">
           <a:xfrm>
-            <a:off x="1454973" y="90558"/>
-            <a:ext cx="10737027" cy="6494085"/>
+            <a:off x="4403464" y="3038139"/>
+            <a:ext cx="2976282" cy="2976282"/>
           </a:xfrm>
           <a:prstGeom prst="rect">
             <a:avLst/>
           </a:prstGeom>
-          <a:solidFill>
-            <a:schemeClr val="tx1"/>
-          </a:solidFill>
+          <a:ln>
+            <a:noFill/>
+          </a:ln>
+          <a:effectLst>
+            <a:outerShdw blurRad="292100" dist="139700" dir="2700000" algn="tl" rotWithShape="0">
+              <a:srgbClr val="333333">
+                <a:alpha val="65000"/>
+              </a:srgbClr>
+            </a:outerShdw>
+          </a:effectLst>
+          <a:extLst>
+            <a:ext uri="{909E8E84-426E-40DD-AFC4-6F175D3DCCD1}">
+              <a14:hiddenFill xmlns:a14="http://schemas.microsoft.com/office/drawing/2010/main">
+                <a:solidFill>
+                  <a:srgbClr val="FFFFFF"/>
+                </a:solidFill>
+              </a14:hiddenFill>
+            </a:ext>
+          </a:extLst>
         </p:spPr>
-        <p:txBody>
-          <a:bodyPr wrap="square">
-            <a:spAutoFit/>
-          </a:bodyPr>
-          <a:lstStyle/>
-          <a:p>
-            <a:pPr marL="0" lvl="1">
-              <a:buNone/>
-            </a:pPr>
-            <a:r>
-              <a:rPr lang="en-US" sz="1600" dirty="0">
-                <a:solidFill>
-                  <a:schemeClr val="bg1"/>
-                </a:solidFill>
-                <a:latin typeface="Aptos Mono" panose="020F0502020204030204" pitchFamily="49" charset="0"/>
-              </a:rPr>
-              <a:t>$moduleInfo = Get-Module PwshSpectreConsole</a:t>
-            </a:r>
-          </a:p>
-          <a:p>
-            <a:pPr marL="0" lvl="1">
-              <a:buNone/>
-            </a:pPr>
-            <a:endParaRPr lang="en-US" sz="1600" noProof="0" dirty="0">
-              <a:solidFill>
-                <a:schemeClr val="bg1"/>
-              </a:solidFill>
-              <a:latin typeface="Aptos Mono" panose="020F0502020204030204" pitchFamily="49" charset="0"/>
-            </a:endParaRPr>
-          </a:p>
-          <a:p>
-            <a:pPr marL="0" lvl="1">
-              <a:buNone/>
-            </a:pPr>
-            <a:r>
-              <a:rPr lang="en-US" sz="1600" dirty="0">
-                <a:solidFill>
-                  <a:schemeClr val="bg1"/>
-                </a:solidFill>
-                <a:latin typeface="Aptos Mono" panose="020F0502020204030204" pitchFamily="49" charset="0"/>
-              </a:rPr>
-              <a:t>New-MarkdownCommandHelp -ModuleInfo $moduleInfo -OutputFolder test -Force -Metadata @{</a:t>
-            </a:r>
-          </a:p>
-          <a:p>
-            <a:pPr marL="0" lvl="1">
-              <a:buNone/>
-            </a:pPr>
-            <a:r>
-              <a:rPr lang="en-US" sz="1600" dirty="0">
-                <a:solidFill>
-                  <a:schemeClr val="bg1"/>
-                </a:solidFill>
-                <a:latin typeface="Aptos Mono" panose="020F0502020204030204" pitchFamily="49" charset="0"/>
-              </a:rPr>
-              <a:t>  sidebar = @{</a:t>
-            </a:r>
-          </a:p>
-          <a:p>
-            <a:pPr marL="0" lvl="1">
-              <a:buNone/>
-            </a:pPr>
-            <a:r>
-              <a:rPr lang="en-US" sz="1600" dirty="0">
-                <a:solidFill>
-                  <a:schemeClr val="bg1"/>
-                </a:solidFill>
-                <a:latin typeface="Aptos Mono" panose="020F0502020204030204" pitchFamily="49" charset="0"/>
-              </a:rPr>
-              <a:t>    badge = @{</a:t>
-            </a:r>
-          </a:p>
-          <a:p>
-            <a:pPr marL="0" lvl="1">
-              <a:buNone/>
-            </a:pPr>
-            <a:r>
-              <a:rPr lang="en-US" sz="1600" dirty="0">
-                <a:solidFill>
-                  <a:schemeClr val="bg1"/>
-                </a:solidFill>
-                <a:latin typeface="Aptos Mono" panose="020F0502020204030204" pitchFamily="49" charset="0"/>
-              </a:rPr>
-              <a:t>      text = "New“</a:t>
-            </a:r>
-          </a:p>
-          <a:p>
-            <a:pPr marL="0" lvl="1">
-              <a:buNone/>
-            </a:pPr>
-            <a:r>
-              <a:rPr lang="en-US" sz="1600" dirty="0">
-                <a:solidFill>
-                  <a:schemeClr val="bg1"/>
-                </a:solidFill>
-                <a:latin typeface="Aptos Mono" panose="020F0502020204030204" pitchFamily="49" charset="0"/>
-              </a:rPr>
-              <a:t>      variant = "tip“</a:t>
-            </a:r>
-          </a:p>
-          <a:p>
-            <a:pPr marL="0" lvl="1">
-              <a:buNone/>
-            </a:pPr>
-            <a:r>
-              <a:rPr lang="en-US" sz="1600" dirty="0">
-                <a:solidFill>
-                  <a:schemeClr val="bg1"/>
-                </a:solidFill>
-                <a:latin typeface="Aptos Mono" panose="020F0502020204030204" pitchFamily="49" charset="0"/>
-              </a:rPr>
-              <a:t>    }</a:t>
-            </a:r>
-          </a:p>
-          <a:p>
-            <a:pPr marL="0" lvl="1">
-              <a:buNone/>
-            </a:pPr>
-            <a:r>
-              <a:rPr lang="en-US" sz="1600" dirty="0">
-                <a:solidFill>
-                  <a:schemeClr val="bg1"/>
-                </a:solidFill>
-                <a:latin typeface="Aptos Mono" panose="020F0502020204030204" pitchFamily="49" charset="0"/>
-              </a:rPr>
-              <a:t>  }</a:t>
-            </a:r>
-          </a:p>
-          <a:p>
-            <a:pPr marL="0" lvl="1">
-              <a:buNone/>
-            </a:pPr>
-            <a:r>
-              <a:rPr lang="en-US" sz="1600" dirty="0">
-                <a:solidFill>
-                  <a:schemeClr val="bg1"/>
-                </a:solidFill>
-                <a:latin typeface="Aptos Mono" panose="020F0502020204030204" pitchFamily="49" charset="0"/>
-              </a:rPr>
-              <a:t>}</a:t>
-            </a:r>
-          </a:p>
-          <a:p>
-            <a:pPr marL="0" lvl="1">
-              <a:buNone/>
-            </a:pPr>
-            <a:endParaRPr lang="en-US" sz="1600" noProof="0" dirty="0">
-              <a:solidFill>
-                <a:schemeClr val="bg1"/>
-              </a:solidFill>
-              <a:latin typeface="Aptos Mono" panose="020F0502020204030204" pitchFamily="49" charset="0"/>
-            </a:endParaRPr>
-          </a:p>
-          <a:p>
-            <a:pPr marL="0" lvl="1">
-              <a:buNone/>
-            </a:pPr>
-            <a:r>
-              <a:rPr lang="en-US" sz="1600" dirty="0">
-                <a:solidFill>
-                  <a:schemeClr val="bg1"/>
-                </a:solidFill>
-                <a:latin typeface="Aptos Mono" panose="020F0502020204030204" pitchFamily="49" charset="0"/>
-              </a:rPr>
-              <a:t>$c -replace '(?ms)## SYNOPSIS.+?^## ', '## ' `    -replace '(?ms)## INPUTS.+?^## ', '## ' `    -replace '(?ms)## OUTPUTS.+?^## ', '## ' `    -replace '(?ms)## NOTES.+?^## ', '## ' `    -replace '(?ms)## RELATED LINKS.+', '' `    -replace '(?ms)## SYNTAX.+?^## ', '## ' `    -replace '(?ms)## ALIASES.+?^## ', '## ‘</a:t>
-            </a:r>
-          </a:p>
-          <a:p>
-            <a:pPr marL="0" lvl="1">
-              <a:buNone/>
-            </a:pPr>
-            <a:endParaRPr lang="en-US" sz="1600" noProof="0" dirty="0">
-              <a:solidFill>
-                <a:schemeClr val="bg1"/>
-              </a:solidFill>
-              <a:latin typeface="Aptos Mono" panose="020F0502020204030204" pitchFamily="49" charset="0"/>
-            </a:endParaRPr>
-          </a:p>
-          <a:p>
-            <a:pPr marL="0" lvl="1">
-              <a:buNone/>
-            </a:pPr>
-            <a:r>
-              <a:rPr lang="en-US" sz="1600" dirty="0">
-                <a:solidFill>
-                  <a:schemeClr val="bg1"/>
-                </a:solidFill>
-                <a:latin typeface="Aptos Mono" panose="020F0502020204030204" pitchFamily="49" charset="0"/>
-              </a:rPr>
-              <a:t>$</a:t>
-            </a:r>
-            <a:r>
-              <a:rPr lang="en-US" sz="1600" dirty="0" err="1">
-                <a:solidFill>
-                  <a:schemeClr val="bg1"/>
-                </a:solidFill>
-                <a:latin typeface="Aptos Mono" panose="020F0502020204030204" pitchFamily="49" charset="0"/>
-              </a:rPr>
-              <a:t>formattedExamples</a:t>
-            </a:r>
-            <a:r>
-              <a:rPr lang="en-US" sz="1600" dirty="0">
-                <a:solidFill>
-                  <a:schemeClr val="bg1"/>
-                </a:solidFill>
-                <a:latin typeface="Aptos Mono" panose="020F0502020204030204" pitchFamily="49" charset="0"/>
-              </a:rPr>
-              <a:t> = $</a:t>
-            </a:r>
-            <a:r>
-              <a:rPr lang="en-US" sz="1600" dirty="0" err="1">
-                <a:solidFill>
-                  <a:schemeClr val="bg1"/>
-                </a:solidFill>
-                <a:latin typeface="Aptos Mono" panose="020F0502020204030204" pitchFamily="49" charset="0"/>
-              </a:rPr>
-              <a:t>commandHelp.Examples</a:t>
-            </a:r>
-            <a:r>
-              <a:rPr lang="en-US" sz="1600" dirty="0">
-                <a:solidFill>
-                  <a:schemeClr val="bg1"/>
-                </a:solidFill>
-                <a:latin typeface="Aptos Mono" panose="020F0502020204030204" pitchFamily="49" charset="0"/>
-              </a:rPr>
-              <a:t> | </a:t>
-            </a:r>
-            <a:r>
-              <a:rPr lang="en-US" sz="1600" dirty="0" err="1">
-                <a:solidFill>
-                  <a:schemeClr val="bg1"/>
-                </a:solidFill>
-                <a:latin typeface="Aptos Mono" panose="020F0502020204030204" pitchFamily="49" charset="0"/>
-              </a:rPr>
-              <a:t>ForEach</a:t>
-            </a:r>
-            <a:r>
-              <a:rPr lang="en-US" sz="1600" dirty="0">
-                <a:solidFill>
-                  <a:schemeClr val="bg1"/>
-                </a:solidFill>
-                <a:latin typeface="Aptos Mono" panose="020F0502020204030204" pitchFamily="49" charset="0"/>
-              </a:rPr>
-              <a:t>-Object {  $_.Remarks = "``````</a:t>
-            </a:r>
-            <a:r>
-              <a:rPr lang="en-US" sz="1600" dirty="0" err="1">
-                <a:solidFill>
-                  <a:schemeClr val="bg1"/>
-                </a:solidFill>
-                <a:latin typeface="Aptos Mono" panose="020F0502020204030204" pitchFamily="49" charset="0"/>
-              </a:rPr>
-              <a:t>pwsh`n</a:t>
-            </a:r>
-            <a:r>
-              <a:rPr lang="en-US" sz="1600" dirty="0">
-                <a:solidFill>
-                  <a:schemeClr val="bg1"/>
-                </a:solidFill>
-                <a:latin typeface="Aptos Mono" panose="020F0502020204030204" pitchFamily="49" charset="0"/>
-              </a:rPr>
-              <a:t>" + $_.Remarks + "`n``````"}</a:t>
-            </a:r>
-          </a:p>
-          <a:p>
-            <a:pPr marL="0" lvl="1">
-              <a:buNone/>
-            </a:pPr>
-            <a:endParaRPr lang="en-US" sz="1600" noProof="0" dirty="0">
-              <a:solidFill>
-                <a:schemeClr val="bg1"/>
-              </a:solidFill>
-              <a:latin typeface="Aptos Mono" panose="020F0502020204030204" pitchFamily="49" charset="0"/>
-            </a:endParaRPr>
-          </a:p>
-          <a:p>
-            <a:pPr marL="0" lvl="1">
-              <a:buNone/>
-            </a:pPr>
-            <a:r>
-              <a:rPr lang="en-US" sz="1600" dirty="0">
-                <a:solidFill>
-                  <a:schemeClr val="bg1"/>
-                </a:solidFill>
-                <a:latin typeface="Aptos Mono" panose="020F0502020204030204" pitchFamily="49" charset="0"/>
-              </a:rPr>
-              <a:t>Export-MarkdownCommandHelp -</a:t>
-            </a:r>
-            <a:r>
-              <a:rPr lang="en-US" sz="1600" dirty="0" err="1">
-                <a:solidFill>
-                  <a:schemeClr val="bg1"/>
-                </a:solidFill>
-                <a:latin typeface="Aptos Mono" panose="020F0502020204030204" pitchFamily="49" charset="0"/>
-              </a:rPr>
-              <a:t>CommandHelp</a:t>
-            </a:r>
-            <a:r>
-              <a:rPr lang="en-US" sz="1600" dirty="0">
-                <a:solidFill>
-                  <a:schemeClr val="bg1"/>
-                </a:solidFill>
-                <a:latin typeface="Aptos Mono" panose="020F0502020204030204" pitchFamily="49" charset="0"/>
-              </a:rPr>
-              <a:t> $</a:t>
-            </a:r>
-            <a:r>
-              <a:rPr lang="en-US" sz="1600" dirty="0" err="1">
-                <a:solidFill>
-                  <a:schemeClr val="bg1"/>
-                </a:solidFill>
-                <a:latin typeface="Aptos Mono" panose="020F0502020204030204" pitchFamily="49" charset="0"/>
-              </a:rPr>
-              <a:t>commandHelp</a:t>
-            </a:r>
-            <a:r>
-              <a:rPr lang="en-US" sz="1600" dirty="0">
-                <a:solidFill>
-                  <a:schemeClr val="bg1"/>
-                </a:solidFill>
-                <a:latin typeface="Aptos Mono" panose="020F0502020204030204" pitchFamily="49" charset="0"/>
-              </a:rPr>
-              <a:t> -OutputFolder .\</a:t>
-            </a:r>
-            <a:r>
-              <a:rPr lang="en-US" sz="1600" dirty="0" err="1">
-                <a:solidFill>
-                  <a:schemeClr val="bg1"/>
-                </a:solidFill>
-                <a:latin typeface="Aptos Mono" panose="020F0502020204030204" pitchFamily="49" charset="0"/>
-              </a:rPr>
-              <a:t>psconfeu</a:t>
-            </a:r>
-            <a:r>
-              <a:rPr lang="en-US" sz="1600" dirty="0">
-                <a:solidFill>
-                  <a:schemeClr val="bg1"/>
-                </a:solidFill>
-                <a:latin typeface="Aptos Mono" panose="020F0502020204030204" pitchFamily="49" charset="0"/>
-              </a:rPr>
-              <a:t>\automagical-documentation\test\tapes\shit\site\</a:t>
-            </a:r>
-            <a:r>
-              <a:rPr lang="en-US" sz="1600" dirty="0" err="1">
-                <a:solidFill>
-                  <a:schemeClr val="bg1"/>
-                </a:solidFill>
-                <a:latin typeface="Aptos Mono" panose="020F0502020204030204" pitchFamily="49" charset="0"/>
-              </a:rPr>
-              <a:t>src</a:t>
-            </a:r>
-            <a:r>
-              <a:rPr lang="en-US" sz="1600" dirty="0">
-                <a:solidFill>
-                  <a:schemeClr val="bg1"/>
-                </a:solidFill>
-                <a:latin typeface="Aptos Mono" panose="020F0502020204030204" pitchFamily="49" charset="0"/>
-              </a:rPr>
-              <a:t>\content\docs\reference –Force</a:t>
-            </a:r>
-          </a:p>
-          <a:p>
-            <a:pPr marL="0" lvl="1">
-              <a:buNone/>
-            </a:pPr>
-            <a:endParaRPr lang="en-US" sz="1600" noProof="0" dirty="0">
-              <a:solidFill>
-                <a:schemeClr val="bg1"/>
-              </a:solidFill>
-              <a:latin typeface="Aptos Mono" panose="020F0502020204030204" pitchFamily="49" charset="0"/>
-            </a:endParaRPr>
-          </a:p>
-          <a:p>
-            <a:pPr marL="0" lvl="1">
-              <a:buNone/>
-            </a:pPr>
-            <a:r>
-              <a:rPr lang="en-US" sz="1600" dirty="0">
-                <a:solidFill>
-                  <a:schemeClr val="bg1"/>
-                </a:solidFill>
-                <a:latin typeface="Aptos Mono" panose="020F0502020204030204" pitchFamily="49" charset="0"/>
-              </a:rPr>
-              <a:t>$c = Get-Content .\psconfeu\automagical-documentation\test\tapes\shit\site\src\content\docs\reference\PwshSpectreConsole\Format-SpectrePanel.md -Raw</a:t>
-            </a:r>
-            <a:endParaRPr lang="en-US" sz="1600" noProof="0" dirty="0">
-              <a:solidFill>
-                <a:schemeClr val="bg1"/>
-              </a:solidFill>
-              <a:latin typeface="Aptos Mono" panose="020F0502020204030204" pitchFamily="49" charset="0"/>
-            </a:endParaRPr>
-          </a:p>
-        </p:txBody>
-      </p:sp>
+      </p:pic>
     </p:spTree>
     <p:extLst>
       <p:ext uri="{BB962C8B-B14F-4D97-AF65-F5344CB8AC3E}">
@@ -7586,7 +7322,7 @@
           <a:p>
             <a:r>
               <a:rPr lang="en-US" sz="4400" noProof="0" dirty="0"/>
-              <a:t>Generate Example Recordings</a:t>
+              <a:t>2. Record the Examples</a:t>
             </a:r>
           </a:p>
         </p:txBody>
@@ -7630,115 +7366,66 @@
             <a:pPr lvl="1"/>
             <a:r>
               <a:rPr lang="en-US" sz="2400" noProof="0" dirty="0"/>
-              <a:t>Records a terminal session via a “tape” file</a:t>
+              <a:t>Record a terminal session via a “tape” file to gif/video</a:t>
             </a:r>
           </a:p>
           <a:p>
             <a:pPr lvl="1"/>
             <a:r>
               <a:rPr lang="en-US" sz="2400" dirty="0"/>
-              <a:t>Convert example comments e.g. </a:t>
+              <a:t>Convert example comments into interactions e.g., “# INPUT: Type 'Hello’”</a:t>
             </a:r>
             <a:endParaRPr lang="en-US" sz="2400" noProof="0" dirty="0"/>
           </a:p>
         </p:txBody>
       </p:sp>
-      <p:sp>
-        <p:nvSpPr>
-          <p:cNvPr id="5" name="TextBox 4">
+      <p:pic>
+        <p:nvPicPr>
+          <p:cNvPr id="1026" name="Picture 2">
             <a:extLst>
               <a:ext uri="{FF2B5EF4-FFF2-40B4-BE49-F238E27FC236}">
-                <a16:creationId xmlns:a16="http://schemas.microsoft.com/office/drawing/2014/main" id="{FE83ADBD-3F6C-1879-2B03-C8D8331D837E}"/>
+                <a16:creationId xmlns:a16="http://schemas.microsoft.com/office/drawing/2014/main" id="{D2FE353B-0F9C-BE96-763C-D55B681DDAFD}"/>
               </a:ext>
             </a:extLst>
           </p:cNvPr>
-          <p:cNvSpPr txBox="1"/>
+          <p:cNvPicPr>
+            <a:picLocks noChangeAspect="1" noChangeArrowheads="1"/>
+          </p:cNvPicPr>
           <p:nvPr/>
-        </p:nvSpPr>
-        <p:spPr>
+        </p:nvPicPr>
+        <p:blipFill>
+          <a:blip r:embed="rId3">
+            <a:extLst>
+              <a:ext uri="{28A0092B-C50C-407E-A947-70E740481C1C}">
+                <a14:useLocalDpi xmlns:a14="http://schemas.microsoft.com/office/drawing/2010/main" val="0"/>
+              </a:ext>
+            </a:extLst>
+          </a:blip>
+          <a:srcRect/>
+          <a:stretch>
+            <a:fillRect/>
+          </a:stretch>
+        </p:blipFill>
+        <p:spPr bwMode="auto">
           <a:xfrm>
-            <a:off x="838200" y="3059668"/>
-            <a:ext cx="10737027" cy="338554"/>
+            <a:off x="3220094" y="2788335"/>
+            <a:ext cx="5751811" cy="3382171"/>
           </a:xfrm>
           <a:prstGeom prst="rect">
             <a:avLst/>
           </a:prstGeom>
-          <a:solidFill>
-            <a:schemeClr val="tx1"/>
-          </a:solidFill>
+          <a:noFill/>
+          <a:extLst>
+            <a:ext uri="{909E8E84-426E-40DD-AFC4-6F175D3DCCD1}">
+              <a14:hiddenFill xmlns:a14="http://schemas.microsoft.com/office/drawing/2010/main">
+                <a:solidFill>
+                  <a:srgbClr val="FFFFFF"/>
+                </a:solidFill>
+              </a14:hiddenFill>
+            </a:ext>
+          </a:extLst>
         </p:spPr>
-        <p:txBody>
-          <a:bodyPr wrap="square">
-            <a:spAutoFit/>
-          </a:bodyPr>
-          <a:lstStyle/>
-          <a:p>
-            <a:pPr marL="0" lvl="1">
-              <a:buNone/>
-            </a:pPr>
-            <a:r>
-              <a:rPr lang="en-US" sz="1600" dirty="0">
-                <a:solidFill>
-                  <a:schemeClr val="bg1"/>
-                </a:solidFill>
-                <a:latin typeface="Aptos Mono" panose="020F0502020204030204" pitchFamily="49" charset="0"/>
-              </a:rPr>
-              <a:t>docker run --rm -v .:/</a:t>
-            </a:r>
-            <a:r>
-              <a:rPr lang="en-US" sz="1600" dirty="0" err="1">
-                <a:solidFill>
-                  <a:schemeClr val="bg1"/>
-                </a:solidFill>
-                <a:latin typeface="Aptos Mono" panose="020F0502020204030204" pitchFamily="49" charset="0"/>
-              </a:rPr>
-              <a:t>vhs</a:t>
-            </a:r>
-            <a:r>
-              <a:rPr lang="en-US" sz="1600" dirty="0">
-                <a:solidFill>
-                  <a:schemeClr val="bg1"/>
-                </a:solidFill>
-                <a:latin typeface="Aptos Mono" panose="020F0502020204030204" pitchFamily="49" charset="0"/>
-              </a:rPr>
-              <a:t> </a:t>
-            </a:r>
-            <a:r>
-              <a:rPr lang="en-US" sz="1600" dirty="0" err="1">
-                <a:solidFill>
-                  <a:schemeClr val="bg1"/>
-                </a:solidFill>
-                <a:latin typeface="Aptos Mono" panose="020F0502020204030204" pitchFamily="49" charset="0"/>
-              </a:rPr>
-              <a:t>vhs-pwsh</a:t>
-            </a:r>
-            <a:r>
-              <a:rPr lang="en-US" sz="1600" dirty="0">
-                <a:solidFill>
-                  <a:schemeClr val="bg1"/>
-                </a:solidFill>
-                <a:latin typeface="Aptos Mono" panose="020F0502020204030204" pitchFamily="49" charset="0"/>
-              </a:rPr>
-              <a:t> </a:t>
-            </a:r>
-            <a:r>
-              <a:rPr lang="en-US" sz="1600" dirty="0" err="1">
-                <a:solidFill>
-                  <a:schemeClr val="bg1"/>
-                </a:solidFill>
-                <a:latin typeface="Aptos Mono" panose="020F0502020204030204" pitchFamily="49" charset="0"/>
-              </a:rPr>
-              <a:t>image.tape</a:t>
-            </a:r>
-            <a:endParaRPr lang="en-US" sz="1600" noProof="0" dirty="0">
-              <a:solidFill>
-                <a:schemeClr val="bg1"/>
-              </a:solidFill>
-              <a:latin typeface="Aptos Mono" panose="020F0502020204030204" pitchFamily="49" charset="0"/>
-            </a:endParaRPr>
-          </a:p>
-        </p:txBody>
-      </p:sp>
+      </p:pic>
     </p:spTree>
     <p:extLst>
       <p:ext uri="{BB962C8B-B14F-4D97-AF65-F5344CB8AC3E}">
@@ -7753,6 +7440,170 @@
 </file>
 
 <file path=ppt/slides/slide14.xml><?xml version="1.0" encoding="utf-8"?>
+<p:sld xmlns:a="http://schemas.openxmlformats.org/drawingml/2006/main" xmlns:r="http://schemas.openxmlformats.org/officeDocument/2006/relationships" xmlns:p="http://schemas.openxmlformats.org/presentationml/2006/main">
+  <p:cSld>
+    <p:spTree>
+      <p:nvGrpSpPr>
+        <p:cNvPr id="1" name="">
+          <a:extLst>
+            <a:ext uri="{FF2B5EF4-FFF2-40B4-BE49-F238E27FC236}">
+              <a16:creationId xmlns:a16="http://schemas.microsoft.com/office/drawing/2014/main" id="{5A82BCA6-3035-9DCA-0F33-663BE4DA9D26}"/>
+            </a:ext>
+          </a:extLst>
+        </p:cNvPr>
+        <p:cNvGrpSpPr/>
+        <p:nvPr/>
+      </p:nvGrpSpPr>
+      <p:grpSpPr>
+        <a:xfrm>
+          <a:off x="0" y="0"/>
+          <a:ext cx="0" cy="0"/>
+          <a:chOff x="0" y="0"/>
+          <a:chExt cx="0" cy="0"/>
+        </a:xfrm>
+      </p:grpSpPr>
+      <p:sp>
+        <p:nvSpPr>
+          <p:cNvPr id="2" name="Titre 1">
+            <a:extLst>
+              <a:ext uri="{FF2B5EF4-FFF2-40B4-BE49-F238E27FC236}">
+                <a16:creationId xmlns:a16="http://schemas.microsoft.com/office/drawing/2014/main" id="{8B731FDA-6F77-7168-85C9-879C2110B615}"/>
+              </a:ext>
+            </a:extLst>
+          </p:cNvPr>
+          <p:cNvSpPr>
+            <a:spLocks noGrp="1"/>
+          </p:cNvSpPr>
+          <p:nvPr>
+            <p:ph type="title"/>
+          </p:nvPr>
+        </p:nvSpPr>
+        <p:spPr/>
+        <p:txBody>
+          <a:bodyPr>
+            <a:normAutofit/>
+          </a:bodyPr>
+          <a:lstStyle/>
+          <a:p>
+            <a:r>
+              <a:rPr lang="en-US" sz="4400" noProof="0" dirty="0"/>
+              <a:t>3. Embed Everything in a Website</a:t>
+            </a:r>
+          </a:p>
+        </p:txBody>
+      </p:sp>
+      <p:sp>
+        <p:nvSpPr>
+          <p:cNvPr id="3" name="Espace réservé du contenu 2">
+            <a:extLst>
+              <a:ext uri="{FF2B5EF4-FFF2-40B4-BE49-F238E27FC236}">
+                <a16:creationId xmlns:a16="http://schemas.microsoft.com/office/drawing/2014/main" id="{F92E9EE4-037D-2CBC-9F24-93FD2B103B40}"/>
+              </a:ext>
+            </a:extLst>
+          </p:cNvPr>
+          <p:cNvSpPr>
+            <a:spLocks noGrp="1"/>
+          </p:cNvSpPr>
+          <p:nvPr>
+            <p:ph idx="1"/>
+          </p:nvPr>
+        </p:nvSpPr>
+        <p:spPr>
+          <a:xfrm>
+            <a:off x="838200" y="1462772"/>
+            <a:ext cx="10801574" cy="4351338"/>
+          </a:xfrm>
+        </p:spPr>
+        <p:txBody>
+          <a:bodyPr/>
+          <a:lstStyle/>
+          <a:p>
+            <a:r>
+              <a:rPr lang="en-US" sz="2800" dirty="0"/>
+              <a:t>Astro Starlight</a:t>
+            </a:r>
+            <a:endParaRPr lang="en-US" sz="2800" noProof="0" dirty="0"/>
+          </a:p>
+          <a:p>
+            <a:pPr lvl="1"/>
+            <a:r>
+              <a:rPr lang="en-US" sz="2400" noProof="0" dirty="0"/>
+              <a:t>Starlight is a document site template like Docusaurus</a:t>
+            </a:r>
+            <a:r>
+              <a:rPr lang="en-US" sz="2400" dirty="0"/>
+              <a:t>, for Astro.</a:t>
+            </a:r>
+          </a:p>
+          <a:p>
+            <a:pPr lvl="1"/>
+            <a:r>
+              <a:rPr lang="en-US" sz="2400" noProof="0" dirty="0"/>
+              <a:t>Ensure Images and Markdown are in the correct place, and we should be good!</a:t>
+            </a:r>
+          </a:p>
+        </p:txBody>
+      </p:sp>
+      <p:pic>
+        <p:nvPicPr>
+          <p:cNvPr id="6" name="Picture 5" descr="A gold star with dots&#10;&#10;AI-generated content may be incorrect.">
+            <a:extLst>
+              <a:ext uri="{FF2B5EF4-FFF2-40B4-BE49-F238E27FC236}">
+                <a16:creationId xmlns:a16="http://schemas.microsoft.com/office/drawing/2014/main" id="{970A4ED6-6BAC-5457-DB96-0EB41ABC851E}"/>
+              </a:ext>
+            </a:extLst>
+          </p:cNvPr>
+          <p:cNvPicPr>
+            <a:picLocks noChangeAspect="1"/>
+          </p:cNvPicPr>
+          <p:nvPr/>
+        </p:nvPicPr>
+        <p:blipFill>
+          <a:blip r:embed="rId3">
+            <a:extLst>
+              <a:ext uri="{28A0092B-C50C-407E-A947-70E740481C1C}">
+                <a14:useLocalDpi xmlns:a14="http://schemas.microsoft.com/office/drawing/2010/main" val="0"/>
+              </a:ext>
+            </a:extLst>
+          </a:blip>
+          <a:stretch>
+            <a:fillRect/>
+          </a:stretch>
+        </p:blipFill>
+        <p:spPr>
+          <a:xfrm>
+            <a:off x="4223006" y="2788335"/>
+            <a:ext cx="3307346" cy="3307346"/>
+          </a:xfrm>
+          <a:prstGeom prst="rect">
+            <a:avLst/>
+          </a:prstGeom>
+          <a:ln>
+            <a:noFill/>
+          </a:ln>
+          <a:effectLst>
+            <a:outerShdw blurRad="292100" dist="139700" dir="2700000" algn="tl" rotWithShape="0">
+              <a:srgbClr val="333333">
+                <a:alpha val="65000"/>
+              </a:srgbClr>
+            </a:outerShdw>
+          </a:effectLst>
+        </p:spPr>
+      </p:pic>
+    </p:spTree>
+    <p:extLst>
+      <p:ext uri="{BB962C8B-B14F-4D97-AF65-F5344CB8AC3E}">
+        <p14:creationId xmlns:p14="http://schemas.microsoft.com/office/powerpoint/2010/main" val="2097105102"/>
+      </p:ext>
+    </p:extLst>
+  </p:cSld>
+  <p:clrMapOvr>
+    <a:masterClrMapping/>
+  </p:clrMapOvr>
+</p:sld>
+</file>
+
+<file path=ppt/slides/slide15.xml><?xml version="1.0" encoding="utf-8"?>
 <p:sld xmlns:a="http://schemas.openxmlformats.org/drawingml/2006/main" xmlns:r="http://schemas.openxmlformats.org/officeDocument/2006/relationships" xmlns:p="http://schemas.openxmlformats.org/presentationml/2006/main">
   <p:cSld>
     <p:spTree>
@@ -7879,319 +7730,6 @@
     <p:extLst>
       <p:ext uri="{BB962C8B-B14F-4D97-AF65-F5344CB8AC3E}">
         <p14:creationId xmlns:p14="http://schemas.microsoft.com/office/powerpoint/2010/main" val="3317259441"/>
-      </p:ext>
-    </p:extLst>
-  </p:cSld>
-  <p:clrMapOvr>
-    <a:masterClrMapping/>
-  </p:clrMapOvr>
-</p:sld>
-</file>
-
-<file path=ppt/slides/slide15.xml><?xml version="1.0" encoding="utf-8"?>
-<p:sld xmlns:a="http://schemas.openxmlformats.org/drawingml/2006/main" xmlns:r="http://schemas.openxmlformats.org/officeDocument/2006/relationships" xmlns:p="http://schemas.openxmlformats.org/presentationml/2006/main">
-  <p:cSld>
-    <p:spTree>
-      <p:nvGrpSpPr>
-        <p:cNvPr id="1" name=""/>
-        <p:cNvGrpSpPr/>
-        <p:nvPr/>
-      </p:nvGrpSpPr>
-      <p:grpSpPr>
-        <a:xfrm>
-          <a:off x="0" y="0"/>
-          <a:ext cx="0" cy="0"/>
-          <a:chOff x="0" y="0"/>
-          <a:chExt cx="0" cy="0"/>
-        </a:xfrm>
-      </p:grpSpPr>
-      <p:sp>
-        <p:nvSpPr>
-          <p:cNvPr id="10" name="Espace réservé du contenu 2">
-            <a:extLst>
-              <a:ext uri="{FF2B5EF4-FFF2-40B4-BE49-F238E27FC236}">
-                <a16:creationId xmlns:a16="http://schemas.microsoft.com/office/drawing/2014/main" id="{F7C3D7A3-288F-C5EC-1A3B-3F23CCB04450}"/>
-              </a:ext>
-            </a:extLst>
-          </p:cNvPr>
-          <p:cNvSpPr txBox="1">
-            <a:spLocks/>
-          </p:cNvSpPr>
-          <p:nvPr/>
-        </p:nvSpPr>
-        <p:spPr>
-          <a:xfrm>
-            <a:off x="830943" y="1665967"/>
-            <a:ext cx="10515600" cy="4351338"/>
-          </a:xfrm>
-          <a:prstGeom prst="rect">
-            <a:avLst/>
-          </a:prstGeom>
-        </p:spPr>
-        <p:txBody>
-          <a:bodyPr vert="horz" lIns="91440" tIns="45720" rIns="91440" bIns="45720" rtlCol="0">
-            <a:normAutofit/>
-          </a:bodyPr>
-          <a:lstStyle>
-            <a:lvl1pPr marL="0" indent="0" algn="l" defTabSz="914400" rtl="0" eaLnBrk="1" latinLnBrk="0" hangingPunct="1">
-              <a:lnSpc>
-                <a:spcPct val="90000"/>
-              </a:lnSpc>
-              <a:spcBef>
-                <a:spcPts val="1000"/>
-              </a:spcBef>
-              <a:buFont typeface="Wingdings" panose="05000000000000000000" pitchFamily="2" charset="2"/>
-              <a:buNone/>
-              <a:defRPr sz="2400" kern="1200">
-                <a:solidFill>
-                  <a:schemeClr val="tx1">
-                    <a:tint val="75000"/>
-                  </a:schemeClr>
-                </a:solidFill>
-                <a:latin typeface="+mn-lt"/>
-                <a:ea typeface="+mn-ea"/>
-                <a:cs typeface="+mn-cs"/>
-              </a:defRPr>
-            </a:lvl1pPr>
-            <a:lvl2pPr marL="457200" indent="0" algn="l" defTabSz="914400" rtl="0" eaLnBrk="1" latinLnBrk="0" hangingPunct="1">
-              <a:lnSpc>
-                <a:spcPct val="90000"/>
-              </a:lnSpc>
-              <a:spcBef>
-                <a:spcPts val="500"/>
-              </a:spcBef>
-              <a:buFont typeface="Wingdings" panose="05000000000000000000" pitchFamily="2" charset="2"/>
-              <a:buNone/>
-              <a:defRPr sz="2000" kern="1200">
-                <a:solidFill>
-                  <a:schemeClr val="tx1">
-                    <a:tint val="75000"/>
-                  </a:schemeClr>
-                </a:solidFill>
-                <a:latin typeface="+mn-lt"/>
-                <a:ea typeface="+mn-ea"/>
-                <a:cs typeface="+mn-cs"/>
-              </a:defRPr>
-            </a:lvl2pPr>
-            <a:lvl3pPr marL="914400" indent="0" algn="l" defTabSz="914400" rtl="0" eaLnBrk="1" latinLnBrk="0" hangingPunct="1">
-              <a:lnSpc>
-                <a:spcPct val="90000"/>
-              </a:lnSpc>
-              <a:spcBef>
-                <a:spcPts val="500"/>
-              </a:spcBef>
-              <a:buFont typeface="Wingdings" panose="05000000000000000000" pitchFamily="2" charset="2"/>
-              <a:buNone/>
-              <a:defRPr sz="1800" kern="1200">
-                <a:solidFill>
-                  <a:schemeClr val="tx1">
-                    <a:tint val="75000"/>
-                  </a:schemeClr>
-                </a:solidFill>
-                <a:latin typeface="+mn-lt"/>
-                <a:ea typeface="+mn-ea"/>
-                <a:cs typeface="+mn-cs"/>
-              </a:defRPr>
-            </a:lvl3pPr>
-            <a:lvl4pPr marL="1371600" indent="0" algn="l" defTabSz="914400" rtl="0" eaLnBrk="1" latinLnBrk="0" hangingPunct="1">
-              <a:lnSpc>
-                <a:spcPct val="90000"/>
-              </a:lnSpc>
-              <a:spcBef>
-                <a:spcPts val="500"/>
-              </a:spcBef>
-              <a:buFont typeface="Wingdings" panose="05000000000000000000" pitchFamily="2" charset="2"/>
-              <a:buNone/>
-              <a:defRPr sz="1600" kern="1200">
-                <a:solidFill>
-                  <a:schemeClr val="tx1">
-                    <a:tint val="75000"/>
-                  </a:schemeClr>
-                </a:solidFill>
-                <a:latin typeface="+mn-lt"/>
-                <a:ea typeface="+mn-ea"/>
-                <a:cs typeface="+mn-cs"/>
-              </a:defRPr>
-            </a:lvl4pPr>
-            <a:lvl5pPr marL="1828800" indent="0" algn="l" defTabSz="914400" rtl="0" eaLnBrk="1" latinLnBrk="0" hangingPunct="1">
-              <a:lnSpc>
-                <a:spcPct val="90000"/>
-              </a:lnSpc>
-              <a:spcBef>
-                <a:spcPts val="500"/>
-              </a:spcBef>
-              <a:buFont typeface="Wingdings" panose="05000000000000000000" pitchFamily="2" charset="2"/>
-              <a:buNone/>
-              <a:defRPr sz="1600" kern="1200">
-                <a:solidFill>
-                  <a:schemeClr val="tx1">
-                    <a:tint val="75000"/>
-                  </a:schemeClr>
-                </a:solidFill>
-                <a:latin typeface="+mn-lt"/>
-                <a:ea typeface="+mn-ea"/>
-                <a:cs typeface="+mn-cs"/>
-              </a:defRPr>
-            </a:lvl5pPr>
-            <a:lvl6pPr marL="2286000" indent="0" algn="l" defTabSz="914400" rtl="0" eaLnBrk="1" latinLnBrk="0" hangingPunct="1">
-              <a:lnSpc>
-                <a:spcPct val="90000"/>
-              </a:lnSpc>
-              <a:spcBef>
-                <a:spcPts val="500"/>
-              </a:spcBef>
-              <a:buFont typeface="Arial" panose="020B0604020202020204" pitchFamily="34" charset="0"/>
-              <a:buNone/>
-              <a:defRPr sz="1600" kern="1200">
-                <a:solidFill>
-                  <a:schemeClr val="tx1">
-                    <a:tint val="75000"/>
-                  </a:schemeClr>
-                </a:solidFill>
-                <a:latin typeface="+mn-lt"/>
-                <a:ea typeface="+mn-ea"/>
-                <a:cs typeface="+mn-cs"/>
-              </a:defRPr>
-            </a:lvl6pPr>
-            <a:lvl7pPr marL="2743200" indent="0" algn="l" defTabSz="914400" rtl="0" eaLnBrk="1" latinLnBrk="0" hangingPunct="1">
-              <a:lnSpc>
-                <a:spcPct val="90000"/>
-              </a:lnSpc>
-              <a:spcBef>
-                <a:spcPts val="500"/>
-              </a:spcBef>
-              <a:buFont typeface="Arial" panose="020B0604020202020204" pitchFamily="34" charset="0"/>
-              <a:buNone/>
-              <a:defRPr sz="1600" kern="1200">
-                <a:solidFill>
-                  <a:schemeClr val="tx1">
-                    <a:tint val="75000"/>
-                  </a:schemeClr>
-                </a:solidFill>
-                <a:latin typeface="+mn-lt"/>
-                <a:ea typeface="+mn-ea"/>
-                <a:cs typeface="+mn-cs"/>
-              </a:defRPr>
-            </a:lvl7pPr>
-            <a:lvl8pPr marL="3200400" indent="0" algn="l" defTabSz="914400" rtl="0" eaLnBrk="1" latinLnBrk="0" hangingPunct="1">
-              <a:lnSpc>
-                <a:spcPct val="90000"/>
-              </a:lnSpc>
-              <a:spcBef>
-                <a:spcPts val="500"/>
-              </a:spcBef>
-              <a:buFont typeface="Arial" panose="020B0604020202020204" pitchFamily="34" charset="0"/>
-              <a:buNone/>
-              <a:defRPr sz="1600" kern="1200">
-                <a:solidFill>
-                  <a:schemeClr val="tx1">
-                    <a:tint val="75000"/>
-                  </a:schemeClr>
-                </a:solidFill>
-                <a:latin typeface="+mn-lt"/>
-                <a:ea typeface="+mn-ea"/>
-                <a:cs typeface="+mn-cs"/>
-              </a:defRPr>
-            </a:lvl8pPr>
-            <a:lvl9pPr marL="3657600" indent="0" algn="l" defTabSz="914400" rtl="0" eaLnBrk="1" latinLnBrk="0" hangingPunct="1">
-              <a:lnSpc>
-                <a:spcPct val="90000"/>
-              </a:lnSpc>
-              <a:spcBef>
-                <a:spcPts val="500"/>
-              </a:spcBef>
-              <a:buFont typeface="Arial" panose="020B0604020202020204" pitchFamily="34" charset="0"/>
-              <a:buNone/>
-              <a:defRPr sz="1600" kern="1200">
-                <a:solidFill>
-                  <a:schemeClr val="tx1">
-                    <a:tint val="75000"/>
-                  </a:schemeClr>
-                </a:solidFill>
-                <a:latin typeface="+mn-lt"/>
-                <a:ea typeface="+mn-ea"/>
-                <a:cs typeface="+mn-cs"/>
-              </a:defRPr>
-            </a:lvl9pPr>
-          </a:lstStyle>
-          <a:p>
-            <a:pPr>
-              <a:buFont typeface="Wingdings" panose="05000000000000000000" pitchFamily="2" charset="2"/>
-              <a:buChar char="§"/>
-            </a:pPr>
-            <a:r>
-              <a:rPr lang="en-US" dirty="0">
-                <a:solidFill>
-                  <a:schemeClr val="tx1"/>
-                </a:solidFill>
-              </a:rPr>
-              <a:t>Hopefully, we don’t need these…</a:t>
-            </a:r>
-          </a:p>
-          <a:p>
-            <a:pPr>
-              <a:buFont typeface="Wingdings" panose="05000000000000000000" pitchFamily="2" charset="2"/>
-              <a:buChar char="§"/>
-            </a:pPr>
-            <a:r>
-              <a:rPr lang="en-US" dirty="0">
-                <a:solidFill>
-                  <a:schemeClr val="tx1"/>
-                </a:solidFill>
-              </a:rPr>
-              <a:t>Problem: I have a module I want online documentation for.</a:t>
-            </a:r>
-          </a:p>
-          <a:p>
-            <a:pPr>
-              <a:buFont typeface="Wingdings" panose="05000000000000000000" pitchFamily="2" charset="2"/>
-              <a:buChar char="§"/>
-            </a:pPr>
-            <a:endParaRPr lang="en-US" dirty="0">
-              <a:solidFill>
-                <a:schemeClr val="tx1"/>
-              </a:solidFill>
-            </a:endParaRPr>
-          </a:p>
-        </p:txBody>
-      </p:sp>
-      <p:sp>
-        <p:nvSpPr>
-          <p:cNvPr id="11" name="Titre 1">
-            <a:extLst>
-              <a:ext uri="{FF2B5EF4-FFF2-40B4-BE49-F238E27FC236}">
-                <a16:creationId xmlns:a16="http://schemas.microsoft.com/office/drawing/2014/main" id="{C3132357-56AF-A8C8-AB98-83E4EF81AF6B}"/>
-              </a:ext>
-            </a:extLst>
-          </p:cNvPr>
-          <p:cNvSpPr>
-            <a:spLocks noGrp="1"/>
-          </p:cNvSpPr>
-          <p:nvPr>
-            <p:ph type="title"/>
-          </p:nvPr>
-        </p:nvSpPr>
-        <p:spPr>
-          <a:xfrm>
-            <a:off x="838200" y="365125"/>
-            <a:ext cx="9733280" cy="1325563"/>
-          </a:xfrm>
-        </p:spPr>
-        <p:txBody>
-          <a:bodyPr/>
-          <a:lstStyle/>
-          <a:p>
-            <a:r>
-              <a:rPr lang="en-US" noProof="0" dirty="0"/>
-              <a:t>Automagical Documentation</a:t>
-            </a:r>
-          </a:p>
-        </p:txBody>
-      </p:sp>
-    </p:spTree>
-    <p:extLst>
-      <p:ext uri="{BB962C8B-B14F-4D97-AF65-F5344CB8AC3E}">
-        <p14:creationId xmlns:p14="http://schemas.microsoft.com/office/powerpoint/2010/main" val="1609993853"/>
       </p:ext>
     </p:extLst>
   </p:cSld>
@@ -10012,7 +9550,7 @@
             </a:pPr>
             <a:r>
               <a:rPr lang="en-US" sz="2400" dirty="0"/>
-              <a:t>Generated from existing comment-based help</a:t>
+              <a:t>Available on the web and in Get-Help</a:t>
             </a:r>
           </a:p>
         </p:txBody>
@@ -10045,6 +9583,16 @@
           <a:prstGeom prst="rect">
             <a:avLst/>
           </a:prstGeom>
+          <a:ln>
+            <a:noFill/>
+          </a:ln>
+          <a:effectLst>
+            <a:outerShdw blurRad="292100" dist="139700" dir="2700000" algn="tl" rotWithShape="0">
+              <a:srgbClr val="333333">
+                <a:alpha val="65000"/>
+              </a:srgbClr>
+            </a:outerShdw>
+          </a:effectLst>
         </p:spPr>
       </p:pic>
     </p:spTree>
@@ -11768,15 +11316,6 @@
 </file>
 
 <file path=customXml/item2.xml><?xml version="1.0" encoding="utf-8"?>
-<?mso-contentType ?>
-<FormTemplates xmlns="http://schemas.microsoft.com/sharepoint/v3/contenttype/forms">
-  <Display>DocumentLibraryForm</Display>
-  <Edit>DocumentLibraryForm</Edit>
-  <New>DocumentLibraryForm</New>
-</FormTemplates>
-</file>
-
-<file path=customXml/item3.xml><?xml version="1.0" encoding="utf-8"?>
 <ct:contentTypeSchema xmlns:ct="http://schemas.microsoft.com/office/2006/metadata/contentType" xmlns:ma="http://schemas.microsoft.com/office/2006/metadata/properties/metaAttributes" ct:_="" ma:_="" ma:contentTypeName="Document" ma:contentTypeID="0x0101006910B4CA76F661498C662C4D69800553" ma:contentTypeVersion="13" ma:contentTypeDescription="Create a new document." ma:contentTypeScope="" ma:versionID="8e04fcd09f7a7dfd06ff4a6ceabf43dc">
   <xsd:schema xmlns:xsd="http://www.w3.org/2001/XMLSchema" xmlns:xs="http://www.w3.org/2001/XMLSchema" xmlns:p="http://schemas.microsoft.com/office/2006/metadata/properties" xmlns:ns2="58c243a5-121d-4837-b81c-114e1b569ece" xmlns:ns3="77f18391-c91f-4725-9130-63caf76c1806" targetNamespace="http://schemas.microsoft.com/office/2006/metadata/properties" ma:root="true" ma:fieldsID="665b7cb087352da028993c4fb985284c" ns2:_="" ns3:_="">
     <xsd:import namespace="58c243a5-121d-4837-b81c-114e1b569ece"/>
@@ -11983,6 +11522,15 @@
 </ct:contentTypeSchema>
 </file>
 
+<file path=customXml/item3.xml><?xml version="1.0" encoding="utf-8"?>
+<?mso-contentType ?>
+<FormTemplates xmlns="http://schemas.microsoft.com/sharepoint/v3/contenttype/forms">
+  <Display>DocumentLibraryForm</Display>
+  <Edit>DocumentLibraryForm</Edit>
+  <New>DocumentLibraryForm</New>
+</FormTemplates>
+</file>
+
 <file path=customXml/itemProps1.xml><?xml version="1.0" encoding="utf-8"?>
 <ds:datastoreItem xmlns:ds="http://schemas.openxmlformats.org/officeDocument/2006/customXml" ds:itemID="{AA9C06E3-346E-408E-B352-32E922A070CE}">
   <ds:schemaRefs>
@@ -11997,14 +11545,6 @@
 </file>
 
 <file path=customXml/itemProps2.xml><?xml version="1.0" encoding="utf-8"?>
-<ds:datastoreItem xmlns:ds="http://schemas.openxmlformats.org/officeDocument/2006/customXml" ds:itemID="{57D9B22B-F436-4FE5-B6C0-65AB2260F593}">
-  <ds:schemaRefs>
-    <ds:schemaRef ds:uri="http://schemas.microsoft.com/sharepoint/v3/contenttype/forms"/>
-  </ds:schemaRefs>
-</ds:datastoreItem>
-</file>
-
-<file path=customXml/itemProps3.xml><?xml version="1.0" encoding="utf-8"?>
 <ds:datastoreItem xmlns:ds="http://schemas.openxmlformats.org/officeDocument/2006/customXml" ds:itemID="{79243F5F-D51B-403B-A401-EA162F276226}">
   <ds:schemaRefs>
     <ds:schemaRef ds:uri="http://schemas.microsoft.com/office/2006/metadata/contentType"/>
@@ -12021,4 +11561,12 @@
     <ds:schemaRef ds:uri="http://schemas.microsoft.com/internal/obd"/>
   </ds:schemaRefs>
 </ds:datastoreItem>
+</file>
+
+<file path=customXml/itemProps3.xml><?xml version="1.0" encoding="utf-8"?>
+<ds:datastoreItem xmlns:ds="http://schemas.openxmlformats.org/officeDocument/2006/customXml" ds:itemID="{57D9B22B-F436-4FE5-B6C0-65AB2260F593}">
+  <ds:schemaRefs>
+    <ds:schemaRef ds:uri="http://schemas.microsoft.com/sharepoint/v3/contenttype/forms"/>
+  </ds:schemaRefs>
+</ds:datastoreItem>
 </file>
</xml_diff>